<commit_message>
creating paperPlots and custom figure notebook
</commit_message>
<xml_diff>
--- a/notes+presentation/final-present.pptx
+++ b/notes+presentation/final-present.pptx
@@ -22,6 +22,8 @@
     <p:sldId id="270" r:id="rId16"/>
     <p:sldId id="271" r:id="rId17"/>
     <p:sldId id="272" r:id="rId18"/>
+    <p:sldId id="273" r:id="rId19"/>
+    <p:sldId id="274" r:id="rId20"/>
   </p:sldIdLst>
   <p:sldSz cx="12192000" cy="6858000"/>
   <p:notesSz cx="6858000" cy="9144000"/>
@@ -5333,6 +5335,1025 @@
 </p:sld>
 </file>
 
+<file path=ppt/slides/slide18.xml><?xml version="1.0" encoding="utf-8"?>
+<p:sld xmlns:a="http://schemas.openxmlformats.org/drawingml/2006/main" xmlns:r="http://schemas.openxmlformats.org/officeDocument/2006/relationships" xmlns:p="http://schemas.openxmlformats.org/presentationml/2006/main">
+  <p:cSld>
+    <p:spTree>
+      <p:nvGrpSpPr>
+        <p:cNvPr id="1" name=""/>
+        <p:cNvGrpSpPr/>
+        <p:nvPr/>
+      </p:nvGrpSpPr>
+      <p:grpSpPr>
+        <a:xfrm>
+          <a:off x="0" y="0"/>
+          <a:ext cx="0" cy="0"/>
+          <a:chOff x="0" y="0"/>
+          <a:chExt cx="0" cy="0"/>
+        </a:xfrm>
+      </p:grpSpPr>
+      <p:grpSp>
+        <p:nvGrpSpPr>
+          <p:cNvPr id="24" name="Group 23">
+            <a:extLst>
+              <a:ext uri="{FF2B5EF4-FFF2-40B4-BE49-F238E27FC236}">
+                <a16:creationId xmlns:a16="http://schemas.microsoft.com/office/drawing/2014/main" id="{7997A6E2-80B7-7C41-A879-C2BDF2E2591D}"/>
+              </a:ext>
+            </a:extLst>
+          </p:cNvPr>
+          <p:cNvGrpSpPr/>
+          <p:nvPr/>
+        </p:nvGrpSpPr>
+        <p:grpSpPr>
+          <a:xfrm>
+            <a:off x="8265716" y="3218123"/>
+            <a:ext cx="3628487" cy="2455075"/>
+            <a:chOff x="8265716" y="3338703"/>
+            <a:chExt cx="3628487" cy="2455075"/>
+          </a:xfrm>
+        </p:grpSpPr>
+        <p:pic>
+          <p:nvPicPr>
+            <p:cNvPr id="9" name="Picture 8">
+              <a:extLst>
+                <a:ext uri="{FF2B5EF4-FFF2-40B4-BE49-F238E27FC236}">
+                  <a16:creationId xmlns:a16="http://schemas.microsoft.com/office/drawing/2014/main" id="{1EAEDE42-51A5-C142-95B1-2B395E09CE5B}"/>
+                </a:ext>
+              </a:extLst>
+            </p:cNvPr>
+            <p:cNvPicPr>
+              <a:picLocks noChangeAspect="1"/>
+            </p:cNvPicPr>
+            <p:nvPr/>
+          </p:nvPicPr>
+          <p:blipFill>
+            <a:blip r:embed="rId2"/>
+            <a:stretch>
+              <a:fillRect/>
+            </a:stretch>
+          </p:blipFill>
+          <p:spPr>
+            <a:xfrm>
+              <a:off x="8265716" y="3338703"/>
+              <a:ext cx="3628487" cy="2438819"/>
+            </a:xfrm>
+            <a:prstGeom prst="rect">
+              <a:avLst/>
+            </a:prstGeom>
+            <a:ln>
+              <a:solidFill>
+                <a:srgbClr val="0070C0"/>
+              </a:solidFill>
+            </a:ln>
+          </p:spPr>
+        </p:pic>
+        <p:sp>
+          <p:nvSpPr>
+            <p:cNvPr id="20" name="TextBox 19">
+              <a:extLst>
+                <a:ext uri="{FF2B5EF4-FFF2-40B4-BE49-F238E27FC236}">
+                  <a16:creationId xmlns:a16="http://schemas.microsoft.com/office/drawing/2014/main" id="{126A3313-C18F-5B43-BE29-F3488606591E}"/>
+                </a:ext>
+              </a:extLst>
+            </p:cNvPr>
+            <p:cNvSpPr txBox="1"/>
+            <p:nvPr/>
+          </p:nvSpPr>
+          <p:spPr>
+            <a:xfrm>
+              <a:off x="8271368" y="5486001"/>
+              <a:ext cx="361741" cy="307777"/>
+            </a:xfrm>
+            <a:prstGeom prst="rect">
+              <a:avLst/>
+            </a:prstGeom>
+            <a:noFill/>
+          </p:spPr>
+          <p:txBody>
+            <a:bodyPr wrap="square" rtlCol="0">
+              <a:spAutoFit/>
+            </a:bodyPr>
+            <a:lstStyle/>
+            <a:p>
+              <a:r>
+                <a:rPr lang="en-VN" sz="1400" b="1" dirty="0"/>
+                <a:t>B</a:t>
+              </a:r>
+              <a:endParaRPr lang="en-VN" b="1" dirty="0"/>
+            </a:p>
+          </p:txBody>
+        </p:sp>
+      </p:grpSp>
+      <p:grpSp>
+        <p:nvGrpSpPr>
+          <p:cNvPr id="23" name="Group 22">
+            <a:extLst>
+              <a:ext uri="{FF2B5EF4-FFF2-40B4-BE49-F238E27FC236}">
+                <a16:creationId xmlns:a16="http://schemas.microsoft.com/office/drawing/2014/main" id="{406ED525-6D43-1344-BE01-9F0B68C7E6D7}"/>
+              </a:ext>
+            </a:extLst>
+          </p:cNvPr>
+          <p:cNvGrpSpPr/>
+          <p:nvPr/>
+        </p:nvGrpSpPr>
+        <p:grpSpPr>
+          <a:xfrm>
+            <a:off x="8265716" y="400527"/>
+            <a:ext cx="3572444" cy="2340567"/>
+            <a:chOff x="8251751" y="487694"/>
+            <a:chExt cx="3572444" cy="2340567"/>
+          </a:xfrm>
+        </p:grpSpPr>
+        <p:pic>
+          <p:nvPicPr>
+            <p:cNvPr id="11" name="Picture 10">
+              <a:extLst>
+                <a:ext uri="{FF2B5EF4-FFF2-40B4-BE49-F238E27FC236}">
+                  <a16:creationId xmlns:a16="http://schemas.microsoft.com/office/drawing/2014/main" id="{0BCEE685-9DAE-B545-A7D0-AFD8ECB4951D}"/>
+                </a:ext>
+              </a:extLst>
+            </p:cNvPr>
+            <p:cNvPicPr>
+              <a:picLocks noChangeAspect="1"/>
+            </p:cNvPicPr>
+            <p:nvPr/>
+          </p:nvPicPr>
+          <p:blipFill>
+            <a:blip r:embed="rId3"/>
+            <a:stretch>
+              <a:fillRect/>
+            </a:stretch>
+          </p:blipFill>
+          <p:spPr>
+            <a:xfrm>
+              <a:off x="8251751" y="487694"/>
+              <a:ext cx="3572444" cy="2340567"/>
+            </a:xfrm>
+            <a:prstGeom prst="rect">
+              <a:avLst/>
+            </a:prstGeom>
+            <a:ln>
+              <a:solidFill>
+                <a:srgbClr val="FF0000"/>
+              </a:solidFill>
+            </a:ln>
+          </p:spPr>
+        </p:pic>
+        <p:sp>
+          <p:nvSpPr>
+            <p:cNvPr id="21" name="TextBox 20">
+              <a:extLst>
+                <a:ext uri="{FF2B5EF4-FFF2-40B4-BE49-F238E27FC236}">
+                  <a16:creationId xmlns:a16="http://schemas.microsoft.com/office/drawing/2014/main" id="{4899AF80-78BF-1E4D-9304-B86F03AB14D1}"/>
+                </a:ext>
+              </a:extLst>
+            </p:cNvPr>
+            <p:cNvSpPr txBox="1"/>
+            <p:nvPr/>
+          </p:nvSpPr>
+          <p:spPr>
+            <a:xfrm>
+              <a:off x="8251751" y="2520484"/>
+              <a:ext cx="361741" cy="307777"/>
+            </a:xfrm>
+            <a:prstGeom prst="rect">
+              <a:avLst/>
+            </a:prstGeom>
+            <a:noFill/>
+          </p:spPr>
+          <p:txBody>
+            <a:bodyPr wrap="square" rtlCol="0">
+              <a:spAutoFit/>
+            </a:bodyPr>
+            <a:lstStyle/>
+            <a:p>
+              <a:r>
+                <a:rPr lang="en-VN" sz="1400" b="1" dirty="0"/>
+                <a:t>A</a:t>
+              </a:r>
+              <a:endParaRPr lang="en-VN" b="1" dirty="0"/>
+            </a:p>
+          </p:txBody>
+        </p:sp>
+      </p:grpSp>
+      <p:grpSp>
+        <p:nvGrpSpPr>
+          <p:cNvPr id="28" name="Group 27">
+            <a:extLst>
+              <a:ext uri="{FF2B5EF4-FFF2-40B4-BE49-F238E27FC236}">
+                <a16:creationId xmlns:a16="http://schemas.microsoft.com/office/drawing/2014/main" id="{7FFD3EEF-BB9C-9849-AABE-25A3B5D911B7}"/>
+              </a:ext>
+            </a:extLst>
+          </p:cNvPr>
+          <p:cNvGrpSpPr/>
+          <p:nvPr/>
+        </p:nvGrpSpPr>
+        <p:grpSpPr>
+          <a:xfrm>
+            <a:off x="339061" y="400527"/>
+            <a:ext cx="7174448" cy="4551505"/>
+            <a:chOff x="518786" y="352691"/>
+            <a:chExt cx="6883120" cy="4335585"/>
+          </a:xfrm>
+        </p:grpSpPr>
+        <p:grpSp>
+          <p:nvGrpSpPr>
+            <p:cNvPr id="22" name="Group 21">
+              <a:extLst>
+                <a:ext uri="{FF2B5EF4-FFF2-40B4-BE49-F238E27FC236}">
+                  <a16:creationId xmlns:a16="http://schemas.microsoft.com/office/drawing/2014/main" id="{4B835597-B9BE-8248-ADF7-3A30C2783252}"/>
+                </a:ext>
+              </a:extLst>
+            </p:cNvPr>
+            <p:cNvGrpSpPr/>
+            <p:nvPr/>
+          </p:nvGrpSpPr>
+          <p:grpSpPr>
+            <a:xfrm>
+              <a:off x="518786" y="352691"/>
+              <a:ext cx="6842928" cy="4335585"/>
+              <a:chOff x="1718268" y="1251298"/>
+              <a:chExt cx="6412513" cy="4174811"/>
+            </a:xfrm>
+          </p:grpSpPr>
+          <p:grpSp>
+            <p:nvGrpSpPr>
+              <p:cNvPr id="12" name="Group 11">
+                <a:extLst>
+                  <a:ext uri="{FF2B5EF4-FFF2-40B4-BE49-F238E27FC236}">
+                    <a16:creationId xmlns:a16="http://schemas.microsoft.com/office/drawing/2014/main" id="{F23AC096-B2A5-1344-9C0E-78434352A7C5}"/>
+                  </a:ext>
+                </a:extLst>
+              </p:cNvPr>
+              <p:cNvGrpSpPr/>
+              <p:nvPr/>
+            </p:nvGrpSpPr>
+            <p:grpSpPr>
+              <a:xfrm>
+                <a:off x="1718268" y="1251298"/>
+                <a:ext cx="6412513" cy="4174811"/>
+                <a:chOff x="1973872" y="1221153"/>
+                <a:chExt cx="6412513" cy="4174811"/>
+              </a:xfrm>
+            </p:grpSpPr>
+            <p:pic>
+              <p:nvPicPr>
+                <p:cNvPr id="5" name="Picture 4">
+                  <a:extLst>
+                    <a:ext uri="{FF2B5EF4-FFF2-40B4-BE49-F238E27FC236}">
+                      <a16:creationId xmlns:a16="http://schemas.microsoft.com/office/drawing/2014/main" id="{4616CD2C-66A3-5148-B3F0-2D7A6A8E65EE}"/>
+                    </a:ext>
+                  </a:extLst>
+                </p:cNvPr>
+                <p:cNvPicPr>
+                  <a:picLocks noChangeAspect="1"/>
+                </p:cNvPicPr>
+                <p:nvPr/>
+              </p:nvPicPr>
+              <p:blipFill rotWithShape="1">
+                <a:blip r:embed="rId4"/>
+                <a:srcRect l="21133"/>
+                <a:stretch/>
+              </p:blipFill>
+              <p:spPr>
+                <a:xfrm>
+                  <a:off x="1973872" y="1221153"/>
+                  <a:ext cx="6412513" cy="4174811"/>
+                </a:xfrm>
+                <a:prstGeom prst="rect">
+                  <a:avLst/>
+                </a:prstGeom>
+                <a:ln w="19050">
+                  <a:noFill/>
+                </a:ln>
+              </p:spPr>
+            </p:pic>
+            <p:sp>
+              <p:nvSpPr>
+                <p:cNvPr id="6" name="Rectangle 5">
+                  <a:extLst>
+                    <a:ext uri="{FF2B5EF4-FFF2-40B4-BE49-F238E27FC236}">
+                      <a16:creationId xmlns:a16="http://schemas.microsoft.com/office/drawing/2014/main" id="{9D3E190F-AEC1-6F42-8928-A08594428E02}"/>
+                    </a:ext>
+                  </a:extLst>
+                </p:cNvPr>
+                <p:cNvSpPr/>
+                <p:nvPr/>
+              </p:nvSpPr>
+              <p:spPr>
+                <a:xfrm>
+                  <a:off x="5325626" y="3657601"/>
+                  <a:ext cx="70338" cy="984738"/>
+                </a:xfrm>
+                <a:prstGeom prst="rect">
+                  <a:avLst/>
+                </a:prstGeom>
+                <a:noFill/>
+                <a:ln w="19050">
+                  <a:solidFill>
+                    <a:srgbClr val="0070C0"/>
+                  </a:solidFill>
+                </a:ln>
+              </p:spPr>
+              <p:style>
+                <a:lnRef idx="2">
+                  <a:schemeClr val="accent1">
+                    <a:shade val="50000"/>
+                  </a:schemeClr>
+                </a:lnRef>
+                <a:fillRef idx="1">
+                  <a:schemeClr val="accent1"/>
+                </a:fillRef>
+                <a:effectRef idx="0">
+                  <a:schemeClr val="accent1"/>
+                </a:effectRef>
+                <a:fontRef idx="minor">
+                  <a:schemeClr val="lt1"/>
+                </a:fontRef>
+              </p:style>
+              <p:txBody>
+                <a:bodyPr rtlCol="0" anchor="ctr"/>
+                <a:lstStyle/>
+                <a:p>
+                  <a:pPr algn="ctr"/>
+                  <a:endParaRPr lang="en-VN" dirty="0"/>
+                </a:p>
+              </p:txBody>
+            </p:sp>
+            <p:sp>
+              <p:nvSpPr>
+                <p:cNvPr id="7" name="Rectangle 6">
+                  <a:extLst>
+                    <a:ext uri="{FF2B5EF4-FFF2-40B4-BE49-F238E27FC236}">
+                      <a16:creationId xmlns:a16="http://schemas.microsoft.com/office/drawing/2014/main" id="{A08A6ECD-9BB7-714C-B85B-2FD471E363ED}"/>
+                    </a:ext>
+                  </a:extLst>
+                </p:cNvPr>
+                <p:cNvSpPr/>
+                <p:nvPr/>
+              </p:nvSpPr>
+              <p:spPr>
+                <a:xfrm>
+                  <a:off x="4392804" y="1627833"/>
+                  <a:ext cx="179196" cy="643094"/>
+                </a:xfrm>
+                <a:prstGeom prst="rect">
+                  <a:avLst/>
+                </a:prstGeom>
+                <a:noFill/>
+                <a:ln w="19050">
+                  <a:solidFill>
+                    <a:srgbClr val="FF0000"/>
+                  </a:solidFill>
+                </a:ln>
+              </p:spPr>
+              <p:style>
+                <a:lnRef idx="2">
+                  <a:schemeClr val="accent1">
+                    <a:shade val="50000"/>
+                  </a:schemeClr>
+                </a:lnRef>
+                <a:fillRef idx="1">
+                  <a:schemeClr val="accent1"/>
+                </a:fillRef>
+                <a:effectRef idx="0">
+                  <a:schemeClr val="accent1"/>
+                </a:effectRef>
+                <a:fontRef idx="minor">
+                  <a:schemeClr val="lt1"/>
+                </a:fontRef>
+              </p:style>
+              <p:txBody>
+                <a:bodyPr rtlCol="0" anchor="ctr"/>
+                <a:lstStyle/>
+                <a:p>
+                  <a:pPr algn="ctr"/>
+                  <a:endParaRPr lang="en-VN" dirty="0"/>
+                </a:p>
+              </p:txBody>
+            </p:sp>
+          </p:grpSp>
+          <p:sp>
+            <p:nvSpPr>
+              <p:cNvPr id="18" name="TextBox 17">
+                <a:extLst>
+                  <a:ext uri="{FF2B5EF4-FFF2-40B4-BE49-F238E27FC236}">
+                    <a16:creationId xmlns:a16="http://schemas.microsoft.com/office/drawing/2014/main" id="{2BB07F4D-5F57-6942-8739-EEF550CD098C}"/>
+                  </a:ext>
+                </a:extLst>
+              </p:cNvPr>
+              <p:cNvSpPr txBox="1"/>
+              <p:nvPr/>
+            </p:nvSpPr>
+            <p:spPr>
+              <a:xfrm>
+                <a:off x="4316396" y="1587638"/>
+                <a:ext cx="361741" cy="307777"/>
+              </a:xfrm>
+              <a:prstGeom prst="rect">
+                <a:avLst/>
+              </a:prstGeom>
+              <a:noFill/>
+            </p:spPr>
+            <p:txBody>
+              <a:bodyPr wrap="square" rtlCol="0">
+                <a:spAutoFit/>
+              </a:bodyPr>
+              <a:lstStyle/>
+              <a:p>
+                <a:r>
+                  <a:rPr lang="en-VN" sz="1400" b="1" dirty="0"/>
+                  <a:t>A</a:t>
+                </a:r>
+                <a:endParaRPr lang="en-VN" b="1" dirty="0"/>
+              </a:p>
+            </p:txBody>
+          </p:sp>
+          <p:sp>
+            <p:nvSpPr>
+              <p:cNvPr id="19" name="TextBox 18">
+                <a:extLst>
+                  <a:ext uri="{FF2B5EF4-FFF2-40B4-BE49-F238E27FC236}">
+                    <a16:creationId xmlns:a16="http://schemas.microsoft.com/office/drawing/2014/main" id="{72851020-BDCD-064F-94EB-21A512DCD110}"/>
+                  </a:ext>
+                </a:extLst>
+              </p:cNvPr>
+              <p:cNvSpPr txBox="1"/>
+              <p:nvPr/>
+            </p:nvSpPr>
+            <p:spPr>
+              <a:xfrm>
+                <a:off x="5140360" y="4404223"/>
+                <a:ext cx="361741" cy="307777"/>
+              </a:xfrm>
+              <a:prstGeom prst="rect">
+                <a:avLst/>
+              </a:prstGeom>
+              <a:noFill/>
+            </p:spPr>
+            <p:txBody>
+              <a:bodyPr wrap="square" rtlCol="0">
+                <a:spAutoFit/>
+              </a:bodyPr>
+              <a:lstStyle/>
+              <a:p>
+                <a:r>
+                  <a:rPr lang="en-VN" sz="1400" b="1" dirty="0"/>
+                  <a:t>B</a:t>
+                </a:r>
+                <a:endParaRPr lang="en-VN" b="1" dirty="0"/>
+              </a:p>
+            </p:txBody>
+          </p:sp>
+        </p:grpSp>
+        <p:pic>
+          <p:nvPicPr>
+            <p:cNvPr id="26" name="Picture 25">
+              <a:extLst>
+                <a:ext uri="{FF2B5EF4-FFF2-40B4-BE49-F238E27FC236}">
+                  <a16:creationId xmlns:a16="http://schemas.microsoft.com/office/drawing/2014/main" id="{D6985A38-06C1-1F49-862C-20D3E36DD020}"/>
+                </a:ext>
+              </a:extLst>
+            </p:cNvPr>
+            <p:cNvPicPr>
+              <a:picLocks noChangeAspect="1"/>
+            </p:cNvPicPr>
+            <p:nvPr/>
+          </p:nvPicPr>
+          <p:blipFill rotWithShape="1">
+            <a:blip r:embed="rId4"/>
+            <a:srcRect t="63634" r="80474" b="16848"/>
+            <a:stretch/>
+          </p:blipFill>
+          <p:spPr>
+            <a:xfrm>
+              <a:off x="5759850" y="728058"/>
+              <a:ext cx="1642056" cy="842753"/>
+            </a:xfrm>
+            <a:prstGeom prst="rect">
+              <a:avLst/>
+            </a:prstGeom>
+          </p:spPr>
+        </p:pic>
+      </p:grpSp>
+      <p:grpSp>
+        <p:nvGrpSpPr>
+          <p:cNvPr id="33" name="Group 32">
+            <a:extLst>
+              <a:ext uri="{FF2B5EF4-FFF2-40B4-BE49-F238E27FC236}">
+                <a16:creationId xmlns:a16="http://schemas.microsoft.com/office/drawing/2014/main" id="{8403462F-00D7-C940-8ED8-FFA8278D3377}"/>
+              </a:ext>
+            </a:extLst>
+          </p:cNvPr>
+          <p:cNvGrpSpPr/>
+          <p:nvPr/>
+        </p:nvGrpSpPr>
+        <p:grpSpPr>
+          <a:xfrm>
+            <a:off x="638094" y="5313653"/>
+            <a:ext cx="7989363" cy="1400889"/>
+            <a:chOff x="638094" y="5313653"/>
+            <a:chExt cx="7989363" cy="1400889"/>
+          </a:xfrm>
+        </p:grpSpPr>
+        <p:pic>
+          <p:nvPicPr>
+            <p:cNvPr id="30" name="Picture 29">
+              <a:extLst>
+                <a:ext uri="{FF2B5EF4-FFF2-40B4-BE49-F238E27FC236}">
+                  <a16:creationId xmlns:a16="http://schemas.microsoft.com/office/drawing/2014/main" id="{601C6073-0326-3A46-8769-D22C8F98002B}"/>
+                </a:ext>
+              </a:extLst>
+            </p:cNvPr>
+            <p:cNvPicPr>
+              <a:picLocks noChangeAspect="1"/>
+            </p:cNvPicPr>
+            <p:nvPr/>
+          </p:nvPicPr>
+          <p:blipFill>
+            <a:blip r:embed="rId5"/>
+            <a:stretch>
+              <a:fillRect/>
+            </a:stretch>
+          </p:blipFill>
+          <p:spPr>
+            <a:xfrm>
+              <a:off x="638094" y="5313653"/>
+              <a:ext cx="6875415" cy="1400889"/>
+            </a:xfrm>
+            <a:prstGeom prst="rect">
+              <a:avLst/>
+            </a:prstGeom>
+          </p:spPr>
+        </p:pic>
+        <p:sp>
+          <p:nvSpPr>
+            <p:cNvPr id="31" name="TextBox 30">
+              <a:extLst>
+                <a:ext uri="{FF2B5EF4-FFF2-40B4-BE49-F238E27FC236}">
+                  <a16:creationId xmlns:a16="http://schemas.microsoft.com/office/drawing/2014/main" id="{9883DA9F-74C3-8B47-A451-1857525BD0E1}"/>
+                </a:ext>
+              </a:extLst>
+            </p:cNvPr>
+            <p:cNvSpPr txBox="1"/>
+            <p:nvPr/>
+          </p:nvSpPr>
+          <p:spPr>
+            <a:xfrm>
+              <a:off x="5793822" y="5656942"/>
+              <a:ext cx="2833635" cy="276999"/>
+            </a:xfrm>
+            <a:prstGeom prst="rect">
+              <a:avLst/>
+            </a:prstGeom>
+            <a:noFill/>
+          </p:spPr>
+          <p:txBody>
+            <a:bodyPr wrap="square" rtlCol="0">
+              <a:spAutoFit/>
+            </a:bodyPr>
+            <a:lstStyle/>
+            <a:p>
+              <a:r>
+                <a:rPr lang="en-VN" sz="1200" b="1" dirty="0"/>
+                <a:t>Full 1-10 micron spectra</a:t>
+              </a:r>
+            </a:p>
+          </p:txBody>
+        </p:sp>
+        <p:sp>
+          <p:nvSpPr>
+            <p:cNvPr id="32" name="Rectangle 31">
+              <a:extLst>
+                <a:ext uri="{FF2B5EF4-FFF2-40B4-BE49-F238E27FC236}">
+                  <a16:creationId xmlns:a16="http://schemas.microsoft.com/office/drawing/2014/main" id="{7DE9C855-CD83-3348-8465-056EBD7EE8E2}"/>
+                </a:ext>
+              </a:extLst>
+            </p:cNvPr>
+            <p:cNvSpPr/>
+            <p:nvPr/>
+          </p:nvSpPr>
+          <p:spPr>
+            <a:xfrm>
+              <a:off x="1728316" y="5365421"/>
+              <a:ext cx="2338857" cy="824364"/>
+            </a:xfrm>
+            <a:prstGeom prst="rect">
+              <a:avLst/>
+            </a:prstGeom>
+            <a:noFill/>
+            <a:ln w="9525">
+              <a:solidFill>
+                <a:schemeClr val="tx1"/>
+              </a:solidFill>
+            </a:ln>
+          </p:spPr>
+          <p:style>
+            <a:lnRef idx="2">
+              <a:schemeClr val="accent1">
+                <a:shade val="50000"/>
+              </a:schemeClr>
+            </a:lnRef>
+            <a:fillRef idx="1">
+              <a:schemeClr val="accent1"/>
+            </a:fillRef>
+            <a:effectRef idx="0">
+              <a:schemeClr val="accent1"/>
+            </a:effectRef>
+            <a:fontRef idx="minor">
+              <a:schemeClr val="lt1"/>
+            </a:fontRef>
+          </p:style>
+          <p:txBody>
+            <a:bodyPr rtlCol="0" anchor="ctr"/>
+            <a:lstStyle/>
+            <a:p>
+              <a:pPr algn="ctr"/>
+              <a:endParaRPr lang="en-VN"/>
+            </a:p>
+          </p:txBody>
+        </p:sp>
+      </p:grpSp>
+    </p:spTree>
+    <p:extLst>
+      <p:ext uri="{BB962C8B-B14F-4D97-AF65-F5344CB8AC3E}">
+        <p14:creationId xmlns:p14="http://schemas.microsoft.com/office/powerpoint/2010/main" val="1027482692"/>
+      </p:ext>
+    </p:extLst>
+  </p:cSld>
+  <p:clrMapOvr>
+    <a:masterClrMapping/>
+  </p:clrMapOvr>
+</p:sld>
+</file>
+
+<file path=ppt/slides/slide19.xml><?xml version="1.0" encoding="utf-8"?>
+<p:sld xmlns:a="http://schemas.openxmlformats.org/drawingml/2006/main" xmlns:r="http://schemas.openxmlformats.org/officeDocument/2006/relationships" xmlns:p="http://schemas.openxmlformats.org/presentationml/2006/main">
+  <p:cSld>
+    <p:spTree>
+      <p:nvGrpSpPr>
+        <p:cNvPr id="1" name=""/>
+        <p:cNvGrpSpPr/>
+        <p:nvPr/>
+      </p:nvGrpSpPr>
+      <p:grpSpPr>
+        <a:xfrm>
+          <a:off x="0" y="0"/>
+          <a:ext cx="0" cy="0"/>
+          <a:chOff x="0" y="0"/>
+          <a:chExt cx="0" cy="0"/>
+        </a:xfrm>
+      </p:grpSpPr>
+      <p:pic>
+        <p:nvPicPr>
+          <p:cNvPr id="4" name="Picture 3">
+            <a:extLst>
+              <a:ext uri="{FF2B5EF4-FFF2-40B4-BE49-F238E27FC236}">
+                <a16:creationId xmlns:a16="http://schemas.microsoft.com/office/drawing/2014/main" id="{A58076EC-549B-5341-99CD-1DA025B3C1BC}"/>
+              </a:ext>
+            </a:extLst>
+          </p:cNvPr>
+          <p:cNvPicPr>
+            <a:picLocks noChangeAspect="1"/>
+          </p:cNvPicPr>
+          <p:nvPr/>
+        </p:nvPicPr>
+        <p:blipFill>
+          <a:blip r:embed="rId2">
+            <a:extLst>
+              <a:ext uri="{BEBA8EAE-BF5A-486C-A8C5-ECC9F3942E4B}">
+                <a14:imgProps xmlns:a14="http://schemas.microsoft.com/office/drawing/2010/main">
+                  <a14:imgLayer r:embed="rId3">
+                    <a14:imgEffect>
+                      <a14:sharpenSoften amount="50000"/>
+                    </a14:imgEffect>
+                    <a14:imgEffect>
+                      <a14:brightnessContrast contrast="-40000"/>
+                    </a14:imgEffect>
+                  </a14:imgLayer>
+                </a14:imgProps>
+              </a:ext>
+            </a:extLst>
+          </a:blip>
+          <a:stretch>
+            <a:fillRect/>
+          </a:stretch>
+        </p:blipFill>
+        <p:spPr>
+          <a:xfrm>
+            <a:off x="161965" y="1506893"/>
+            <a:ext cx="4371545" cy="4126055"/>
+          </a:xfrm>
+          <a:prstGeom prst="rect">
+            <a:avLst/>
+          </a:prstGeom>
+        </p:spPr>
+      </p:pic>
+      <p:grpSp>
+        <p:nvGrpSpPr>
+          <p:cNvPr id="13" name="Group 12">
+            <a:extLst>
+              <a:ext uri="{FF2B5EF4-FFF2-40B4-BE49-F238E27FC236}">
+                <a16:creationId xmlns:a16="http://schemas.microsoft.com/office/drawing/2014/main" id="{BFD07545-64CC-354B-BED8-49FC36D1AE9D}"/>
+              </a:ext>
+            </a:extLst>
+          </p:cNvPr>
+          <p:cNvGrpSpPr/>
+          <p:nvPr/>
+        </p:nvGrpSpPr>
+        <p:grpSpPr>
+          <a:xfrm>
+            <a:off x="4834080" y="2126020"/>
+            <a:ext cx="6503811" cy="3506928"/>
+            <a:chOff x="5087241" y="1615617"/>
+            <a:chExt cx="6503811" cy="3506928"/>
+          </a:xfrm>
+        </p:grpSpPr>
+        <p:grpSp>
+          <p:nvGrpSpPr>
+            <p:cNvPr id="10" name="Group 9">
+              <a:extLst>
+                <a:ext uri="{FF2B5EF4-FFF2-40B4-BE49-F238E27FC236}">
+                  <a16:creationId xmlns:a16="http://schemas.microsoft.com/office/drawing/2014/main" id="{EA3239DC-CF38-174C-B5B6-E3384D7BF855}"/>
+                </a:ext>
+              </a:extLst>
+            </p:cNvPr>
+            <p:cNvGrpSpPr/>
+            <p:nvPr/>
+          </p:nvGrpSpPr>
+          <p:grpSpPr>
+            <a:xfrm>
+              <a:off x="5087241" y="1615617"/>
+              <a:ext cx="6503811" cy="3237736"/>
+              <a:chOff x="3481347" y="1273973"/>
+              <a:chExt cx="7169905" cy="3569332"/>
+            </a:xfrm>
+          </p:grpSpPr>
+          <p:pic>
+            <p:nvPicPr>
+              <p:cNvPr id="5" name="Picture 4">
+                <a:extLst>
+                  <a:ext uri="{FF2B5EF4-FFF2-40B4-BE49-F238E27FC236}">
+                    <a16:creationId xmlns:a16="http://schemas.microsoft.com/office/drawing/2014/main" id="{1EA6363A-7D77-BC42-A933-CB11908C6C1D}"/>
+                  </a:ext>
+                </a:extLst>
+              </p:cNvPr>
+              <p:cNvPicPr>
+                <a:picLocks noChangeAspect="1"/>
+              </p:cNvPicPr>
+              <p:nvPr/>
+            </p:nvPicPr>
+            <p:blipFill rotWithShape="1">
+              <a:blip r:embed="rId4"/>
+              <a:srcRect l="4098" t="9380" r="25169" b="49596"/>
+              <a:stretch/>
+            </p:blipFill>
+            <p:spPr>
+              <a:xfrm>
+                <a:off x="3664045" y="1778557"/>
+                <a:ext cx="6987207" cy="3064748"/>
+              </a:xfrm>
+              <a:prstGeom prst="rect">
+                <a:avLst/>
+              </a:prstGeom>
+            </p:spPr>
+          </p:pic>
+          <p:pic>
+            <p:nvPicPr>
+              <p:cNvPr id="6" name="Picture 5">
+                <a:extLst>
+                  <a:ext uri="{FF2B5EF4-FFF2-40B4-BE49-F238E27FC236}">
+                    <a16:creationId xmlns:a16="http://schemas.microsoft.com/office/drawing/2014/main" id="{160CB2E4-21FF-4248-89BF-FF11A3DDEC6E}"/>
+                  </a:ext>
+                </a:extLst>
+              </p:cNvPr>
+              <p:cNvPicPr>
+                <a:picLocks noChangeAspect="1"/>
+              </p:cNvPicPr>
+              <p:nvPr/>
+            </p:nvPicPr>
+            <p:blipFill rotWithShape="1">
+              <a:blip r:embed="rId4"/>
+              <a:srcRect l="419" t="39251" r="96530" b="35227"/>
+              <a:stretch/>
+            </p:blipFill>
+            <p:spPr>
+              <a:xfrm>
+                <a:off x="3481347" y="2542232"/>
+                <a:ext cx="182698" cy="1155561"/>
+              </a:xfrm>
+              <a:prstGeom prst="rect">
+                <a:avLst/>
+              </a:prstGeom>
+            </p:spPr>
+          </p:pic>
+          <p:pic>
+            <p:nvPicPr>
+              <p:cNvPr id="7" name="Picture 6">
+                <a:extLst>
+                  <a:ext uri="{FF2B5EF4-FFF2-40B4-BE49-F238E27FC236}">
+                    <a16:creationId xmlns:a16="http://schemas.microsoft.com/office/drawing/2014/main" id="{6BAB320C-65A2-E442-A93E-1195602FD0C7}"/>
+                  </a:ext>
+                </a:extLst>
+              </p:cNvPr>
+              <p:cNvPicPr>
+                <a:picLocks noChangeAspect="1"/>
+              </p:cNvPicPr>
+              <p:nvPr/>
+            </p:nvPicPr>
+            <p:blipFill rotWithShape="1">
+              <a:blip r:embed="rId4"/>
+              <a:srcRect l="35903" t="155" r="30916" b="90302"/>
+              <a:stretch/>
+            </p:blipFill>
+            <p:spPr>
+              <a:xfrm>
+                <a:off x="5958672" y="1273973"/>
+                <a:ext cx="1986959" cy="432079"/>
+              </a:xfrm>
+              <a:prstGeom prst="rect">
+                <a:avLst/>
+              </a:prstGeom>
+            </p:spPr>
+          </p:pic>
+          <p:pic>
+            <p:nvPicPr>
+              <p:cNvPr id="8" name="Picture 7">
+                <a:extLst>
+                  <a:ext uri="{FF2B5EF4-FFF2-40B4-BE49-F238E27FC236}">
+                    <a16:creationId xmlns:a16="http://schemas.microsoft.com/office/drawing/2014/main" id="{08D22B7D-BDB6-574D-A502-8B014EE2EEF5}"/>
+                  </a:ext>
+                </a:extLst>
+              </p:cNvPr>
+              <p:cNvPicPr>
+                <a:picLocks noChangeAspect="1"/>
+              </p:cNvPicPr>
+              <p:nvPr/>
+            </p:nvPicPr>
+            <p:blipFill rotWithShape="1">
+              <a:blip r:embed="rId4"/>
+              <a:srcRect l="9726" t="80977" r="75585" b="9036"/>
+              <a:stretch/>
+            </p:blipFill>
+            <p:spPr>
+              <a:xfrm>
+                <a:off x="9075420" y="3888712"/>
+                <a:ext cx="1133705" cy="582806"/>
+              </a:xfrm>
+              <a:prstGeom prst="rect">
+                <a:avLst/>
+              </a:prstGeom>
+            </p:spPr>
+          </p:pic>
+        </p:grpSp>
+        <p:pic>
+          <p:nvPicPr>
+            <p:cNvPr id="11" name="Picture 10">
+              <a:extLst>
+                <a:ext uri="{FF2B5EF4-FFF2-40B4-BE49-F238E27FC236}">
+                  <a16:creationId xmlns:a16="http://schemas.microsoft.com/office/drawing/2014/main" id="{CDD8889E-3339-FD4A-8AC8-AA1F55D8AFA3}"/>
+                </a:ext>
+              </a:extLst>
+            </p:cNvPr>
+            <p:cNvPicPr>
+              <a:picLocks noChangeAspect="1"/>
+            </p:cNvPicPr>
+            <p:nvPr/>
+          </p:nvPicPr>
+          <p:blipFill rotWithShape="1">
+            <a:blip r:embed="rId4"/>
+            <a:srcRect l="30870" t="95487" r="20910"/>
+            <a:stretch/>
+          </p:blipFill>
+          <p:spPr>
+            <a:xfrm>
+              <a:off x="6903219" y="4919122"/>
+              <a:ext cx="2873828" cy="203423"/>
+            </a:xfrm>
+            <a:prstGeom prst="rect">
+              <a:avLst/>
+            </a:prstGeom>
+          </p:spPr>
+        </p:pic>
+      </p:grpSp>
+      <p:sp>
+        <p:nvSpPr>
+          <p:cNvPr id="14" name="TextBox 13">
+            <a:extLst>
+              <a:ext uri="{FF2B5EF4-FFF2-40B4-BE49-F238E27FC236}">
+                <a16:creationId xmlns:a16="http://schemas.microsoft.com/office/drawing/2014/main" id="{6B58BEF8-0F18-D541-BC6F-50825BB86873}"/>
+              </a:ext>
+            </a:extLst>
+          </p:cNvPr>
+          <p:cNvSpPr txBox="1"/>
+          <p:nvPr/>
+        </p:nvSpPr>
+        <p:spPr>
+          <a:xfrm>
+            <a:off x="4999805" y="1451049"/>
+            <a:ext cx="6669136" cy="523220"/>
+          </a:xfrm>
+          <a:prstGeom prst="rect">
+            <a:avLst/>
+          </a:prstGeom>
+          <a:noFill/>
+        </p:spPr>
+        <p:txBody>
+          <a:bodyPr wrap="square" rtlCol="0">
+            <a:spAutoFit/>
+          </a:bodyPr>
+          <a:lstStyle/>
+          <a:p>
+            <a:r>
+              <a:rPr lang="en-VN" sz="1400" b="1" dirty="0"/>
+              <a:t>PICASO-simulated anti-correlation of Na2S and MgSiO3 clouds resulted in anti-correlation between short- and long-wavelength light curves similar to observation.</a:t>
+            </a:r>
+          </a:p>
+        </p:txBody>
+      </p:sp>
+      <p:sp>
+        <p:nvSpPr>
+          <p:cNvPr id="15" name="TextBox 14">
+            <a:extLst>
+              <a:ext uri="{FF2B5EF4-FFF2-40B4-BE49-F238E27FC236}">
+                <a16:creationId xmlns:a16="http://schemas.microsoft.com/office/drawing/2014/main" id="{11094695-AEDC-9D40-8C4F-E08CF3ABD9F4}"/>
+              </a:ext>
+            </a:extLst>
+          </p:cNvPr>
+          <p:cNvSpPr txBox="1"/>
+          <p:nvPr/>
+        </p:nvSpPr>
+        <p:spPr>
+          <a:xfrm>
+            <a:off x="712869" y="5750184"/>
+            <a:ext cx="2853732" cy="307777"/>
+          </a:xfrm>
+          <a:prstGeom prst="rect">
+            <a:avLst/>
+          </a:prstGeom>
+          <a:noFill/>
+        </p:spPr>
+        <p:txBody>
+          <a:bodyPr wrap="square" rtlCol="0">
+            <a:spAutoFit/>
+          </a:bodyPr>
+          <a:lstStyle/>
+          <a:p>
+            <a:r>
+              <a:rPr lang="en-VN" sz="1400" b="1" i="1" dirty="0"/>
+              <a:t>Picaso-simulated Light Curves </a:t>
+            </a:r>
+          </a:p>
+        </p:txBody>
+      </p:sp>
+      <p:sp>
+        <p:nvSpPr>
+          <p:cNvPr id="16" name="TextBox 15">
+            <a:extLst>
+              <a:ext uri="{FF2B5EF4-FFF2-40B4-BE49-F238E27FC236}">
+                <a16:creationId xmlns:a16="http://schemas.microsoft.com/office/drawing/2014/main" id="{BA4A912C-07C7-7644-8528-E4ABFA24E02F}"/>
+              </a:ext>
+            </a:extLst>
+          </p:cNvPr>
+          <p:cNvSpPr txBox="1"/>
+          <p:nvPr/>
+        </p:nvSpPr>
+        <p:spPr>
+          <a:xfrm>
+            <a:off x="5282807" y="5750183"/>
+            <a:ext cx="4835883" cy="307777"/>
+          </a:xfrm>
+          <a:prstGeom prst="rect">
+            <a:avLst/>
+          </a:prstGeom>
+          <a:noFill/>
+        </p:spPr>
+        <p:txBody>
+          <a:bodyPr wrap="square" rtlCol="0">
+            <a:spAutoFit/>
+          </a:bodyPr>
+          <a:lstStyle/>
+          <a:p>
+            <a:r>
+              <a:rPr lang="en-VN" sz="1400" b="1" i="1" dirty="0"/>
+              <a:t>Spitzer &amp; HST Light Curve of 2M2228 (Yang et al. 2016)</a:t>
+            </a:r>
+          </a:p>
+        </p:txBody>
+      </p:sp>
+    </p:spTree>
+    <p:extLst>
+      <p:ext uri="{BB962C8B-B14F-4D97-AF65-F5344CB8AC3E}">
+        <p14:creationId xmlns:p14="http://schemas.microsoft.com/office/powerpoint/2010/main" val="716073726"/>
+      </p:ext>
+    </p:extLst>
+  </p:cSld>
+  <p:clrMapOvr>
+    <a:masterClrMapping/>
+  </p:clrMapOvr>
+</p:sld>
+</file>
+
 <file path=ppt/slides/slide2.xml><?xml version="1.0" encoding="utf-8"?>
 <p:sld xmlns:a="http://schemas.openxmlformats.org/drawingml/2006/main" xmlns:r="http://schemas.openxmlformats.org/officeDocument/2006/relationships" xmlns:p="http://schemas.openxmlformats.org/presentationml/2006/main">
   <p:cSld>

</xml_diff>